<commit_message>
docs: add revision-workflow section to the meta-playbook
Documents how the fork/practice + weekly-report revision cycle actually
ran, as a reusable template for the next revision:

- What triggered it (a live user question surfacing a real gap)
- The 7-step revision sequence (answer -> update playbook -> build
  mechanism -> propagate to all 4 files -> verify each -> commit/push/
  checksum-verify -> update playbook's own inventory)
- A reusable Revision Checklist table
- The two bugs caught this cycle, generalized into a pattern: font-
  coverage bugs cluster at code/URL boundaries inside translated text,
  higher risk than plain paragraphs
- Key lesson: one concept change costs 4 files x 4 verifications in a
  bilingual multi-format tutorial — budget accordingly

Applied to GSTACK_TUTORIAL_1_WORKFLOW_PLAYBOOK.docx (new H1 section)
and GSTACK_TUTORIAL_1_WORKFLOW_PLAYBOOK_DECK.pptx (+2 slides, 8->10).

Co-Authored-By: Claude Sonnet 5 <noreply@anthropic.com>
</commit_message>
<xml_diff>
--- a/GSTACK_TUTORIAL_1_WORKFLOW_PLAYBOOK_DECK.pptx
+++ b/GSTACK_TUTORIAL_1_WORKFLOW_PLAYBOOK_DECK.pptx
@@ -13,9 +13,11 @@
     <p:sldId id="261" r:id="rId7"/>
     <p:sldId id="262" r:id="rId8"/>
     <p:sldId id="263" r:id="rId9"/>
+    <p:sldId id="264" r:id="rId10"/>
+    <p:sldId id="265" r:id="rId11"/>
   </p:sldIdLst>
   <p:notesMasterIdLst>
-    <p:notesMasterId r:id="rId10"/>
+    <p:notesMasterId r:id="rId12"/>
   </p:notesMasterIdLst>
   <p:sldSz cx="12192000" cy="6858000"/>
   <p:notesSz cx="6858000" cy="12192000"/>
@@ -551,6 +553,94 @@
 </p:notes>
 </file>
 
+<file path=ppt/notesSlides/notesSlide10.xml><?xml version="1.0" encoding="utf-8"?>
+<p:notes xmlns:a="http://schemas.openxmlformats.org/drawingml/2006/main" xmlns:r="http://schemas.openxmlformats.org/officeDocument/2006/relationships" xmlns:p="http://schemas.openxmlformats.org/presentationml/2006/main">
+  <p:cSld>
+    <p:spTree>
+      <p:nvGrpSpPr>
+        <p:cNvPr id="1" name=""/>
+        <p:cNvGrpSpPr/>
+        <p:nvPr/>
+      </p:nvGrpSpPr>
+      <p:grpSpPr>
+        <a:xfrm>
+          <a:off x="0" y="0"/>
+          <a:ext cx="0" cy="0"/>
+          <a:chOff x="0" y="0"/>
+          <a:chExt cx="0" cy="0"/>
+        </a:xfrm>
+      </p:grpSpPr>
+      <p:sp>
+        <p:nvSpPr>
+          <p:cNvPr id="2" name="Slide Image Placeholder 1"/>
+          <p:cNvSpPr>
+            <a:spLocks noGrp="1" noRot="1" noChangeAspect="1"/>
+          </p:cNvSpPr>
+          <p:nvPr>
+            <p:ph type="sldImg"/>
+          </p:nvPr>
+        </p:nvSpPr>
+        <p:spPr/>
+      </p:sp>
+      <p:sp>
+        <p:nvSpPr>
+          <p:cNvPr id="3" name="Notes Placeholder 2"/>
+          <p:cNvSpPr>
+            <a:spLocks noGrp="1"/>
+          </p:cNvSpPr>
+          <p:nvPr>
+            <p:ph type="body" idx="1"/>
+          </p:nvPr>
+        </p:nvSpPr>
+        <p:spPr/>
+        <p:txBody>
+          <a:bodyPr/>
+          <a:lstStyle/>
+          <a:p>
+            <a:r>
+              <a:rPr lang="en-US" dirty="0"/>
+              <a:t/>
+            </a:r>
+            <a:endParaRPr lang="en-US" dirty="0"/>
+          </a:p>
+        </p:txBody>
+      </p:sp>
+      <p:sp>
+        <p:nvSpPr>
+          <p:cNvPr id="4" name="Slide Number Placeholder 3"/>
+          <p:cNvSpPr>
+            <a:spLocks noGrp="1"/>
+          </p:cNvSpPr>
+          <p:nvPr>
+            <p:ph type="sldNum" sz="quarter" idx="10"/>
+          </p:nvPr>
+        </p:nvSpPr>
+        <p:spPr/>
+        <p:txBody>
+          <a:bodyPr/>
+          <a:lstStyle/>
+          <a:p>
+            <a:fld id="{F7021451-1387-4CA6-816F-3879F97B5CBC}" type="slidenum">
+              <a:rPr lang="en-US"/>
+              <a:t>10</a:t>
+            </a:fld>
+            <a:endParaRPr lang="en-US"/>
+          </a:p>
+        </p:txBody>
+      </p:sp>
+    </p:spTree>
+    <p:extLst>
+      <p:ext uri="{BB962C8B-B14F-4D97-AF65-F5344CB8AC3E}">
+        <p14:creationId xmlns:p14="http://schemas.microsoft.com/office/powerpoint/2010/main" val="1024086991"/>
+      </p:ext>
+    </p:extLst>
+  </p:cSld>
+  <p:clrMapOvr>
+    <a:masterClrMapping/>
+  </p:clrMapOvr>
+</p:notes>
+</file>
+
 <file path=ppt/notesSlides/notesSlide2.xml><?xml version="1.0" encoding="utf-8"?>
 <p:notes xmlns:a="http://schemas.openxmlformats.org/drawingml/2006/main" xmlns:r="http://schemas.openxmlformats.org/officeDocument/2006/relationships" xmlns:p="http://schemas.openxmlformats.org/presentationml/2006/main">
   <p:cSld>
@@ -1149,6 +1239,94 @@
             <a:fld id="{F7021451-1387-4CA6-816F-3879F97B5CBC}" type="slidenum">
               <a:rPr lang="en-US"/>
               <a:t>8</a:t>
+            </a:fld>
+            <a:endParaRPr lang="en-US"/>
+          </a:p>
+        </p:txBody>
+      </p:sp>
+    </p:spTree>
+    <p:extLst>
+      <p:ext uri="{BB962C8B-B14F-4D97-AF65-F5344CB8AC3E}">
+        <p14:creationId xmlns:p14="http://schemas.microsoft.com/office/powerpoint/2010/main" val="1024086991"/>
+      </p:ext>
+    </p:extLst>
+  </p:cSld>
+  <p:clrMapOvr>
+    <a:masterClrMapping/>
+  </p:clrMapOvr>
+</p:notes>
+</file>
+
+<file path=ppt/notesSlides/notesSlide9.xml><?xml version="1.0" encoding="utf-8"?>
+<p:notes xmlns:a="http://schemas.openxmlformats.org/drawingml/2006/main" xmlns:r="http://schemas.openxmlformats.org/officeDocument/2006/relationships" xmlns:p="http://schemas.openxmlformats.org/presentationml/2006/main">
+  <p:cSld>
+    <p:spTree>
+      <p:nvGrpSpPr>
+        <p:cNvPr id="1" name=""/>
+        <p:cNvGrpSpPr/>
+        <p:nvPr/>
+      </p:nvGrpSpPr>
+      <p:grpSpPr>
+        <a:xfrm>
+          <a:off x="0" y="0"/>
+          <a:ext cx="0" cy="0"/>
+          <a:chOff x="0" y="0"/>
+          <a:chExt cx="0" cy="0"/>
+        </a:xfrm>
+      </p:grpSpPr>
+      <p:sp>
+        <p:nvSpPr>
+          <p:cNvPr id="2" name="Slide Image Placeholder 1"/>
+          <p:cNvSpPr>
+            <a:spLocks noGrp="1" noRot="1" noChangeAspect="1"/>
+          </p:cNvSpPr>
+          <p:nvPr>
+            <p:ph type="sldImg"/>
+          </p:nvPr>
+        </p:nvSpPr>
+        <p:spPr/>
+      </p:sp>
+      <p:sp>
+        <p:nvSpPr>
+          <p:cNvPr id="3" name="Notes Placeholder 2"/>
+          <p:cNvSpPr>
+            <a:spLocks noGrp="1"/>
+          </p:cNvSpPr>
+          <p:nvPr>
+            <p:ph type="body" idx="1"/>
+          </p:nvPr>
+        </p:nvSpPr>
+        <p:spPr/>
+        <p:txBody>
+          <a:bodyPr/>
+          <a:lstStyle/>
+          <a:p>
+            <a:r>
+              <a:rPr lang="en-US" dirty="0"/>
+              <a:t/>
+            </a:r>
+            <a:endParaRPr lang="en-US" dirty="0"/>
+          </a:p>
+        </p:txBody>
+      </p:sp>
+      <p:sp>
+        <p:nvSpPr>
+          <p:cNvPr id="4" name="Slide Number Placeholder 3"/>
+          <p:cNvSpPr>
+            <a:spLocks noGrp="1"/>
+          </p:cNvSpPr>
+          <p:nvPr>
+            <p:ph type="sldNum" sz="quarter" idx="10"/>
+          </p:nvPr>
+        </p:nvSpPr>
+        <p:spPr/>
+        <p:txBody>
+          <a:bodyPr/>
+          <a:lstStyle/>
+          <a:p>
+            <a:fld id="{F7021451-1387-4CA6-816F-3879F97B5CBC}" type="slidenum">
+              <a:rPr lang="en-US"/>
+              <a:t>9</a:t>
             </a:fld>
             <a:endParaRPr lang="en-US"/>
           </a:p>
@@ -1662,6 +1840,410 @@
 </p:sld>
 </file>
 
+<file path=ppt/slides/slide10.xml><?xml version="1.0" encoding="utf-8"?>
+<p:sld xmlns:a="http://schemas.openxmlformats.org/drawingml/2006/main" xmlns:r="http://schemas.openxmlformats.org/officeDocument/2006/relationships" xmlns:p="http://schemas.openxmlformats.org/presentationml/2006/main">
+  <p:cSld name="Slide 10">
+    <p:bg>
+      <p:bgPr>
+        <a:solidFill>
+          <a:srgbClr val="16374F"/>
+        </a:solidFill>
+      </p:bgPr>
+    </p:bg>
+    <p:spTree>
+      <p:nvGrpSpPr>
+        <p:cNvPr id="1" name=""/>
+        <p:cNvGrpSpPr/>
+        <p:nvPr/>
+      </p:nvGrpSpPr>
+      <p:grpSpPr>
+        <a:xfrm>
+          <a:off x="0" y="0"/>
+          <a:ext cx="0" cy="0"/>
+          <a:chOff x="0" y="0"/>
+          <a:chExt cx="0" cy="0"/>
+        </a:xfrm>
+      </p:grpSpPr>
+      <p:sp>
+        <p:nvSpPr>
+          <p:cNvPr id="2" name="Text 0"/>
+          <p:cNvSpPr/>
+          <p:nvPr/>
+        </p:nvSpPr>
+        <p:spPr>
+          <a:xfrm>
+            <a:off x="731520" y="731520"/>
+            <a:ext cx="10698480" cy="914400"/>
+          </a:xfrm>
+          <a:prstGeom prst="rect">
+            <a:avLst/>
+          </a:prstGeom>
+          <a:noFill/>
+          <a:ln/>
+        </p:spPr>
+        <p:txBody>
+          <a:bodyPr wrap="square" lIns="0" tIns="0" rIns="0" bIns="0" rtlCol="0" anchor="ctr"/>
+          <a:lstStyle/>
+          <a:p>
+            <a:pPr indent="0" marL="0">
+              <a:buNone/>
+            </a:pPr>
+            <a:r>
+              <a:rPr lang="en-US" sz="3600" b="1" dirty="0">
+                <a:solidFill>
+                  <a:srgbClr val="FFFFFF"/>
+                </a:solidFill>
+                <a:latin typeface="Cambria" pitchFamily="34" charset="0"/>
+                <a:ea typeface="Cambria" pitchFamily="34" charset="-122"/>
+                <a:cs typeface="Cambria" pitchFamily="34" charset="-120"/>
+              </a:rPr>
+              <a:t>Ready for Tutorial #2</a:t>
+            </a:r>
+            <a:endParaRPr lang="en-US" sz="3600" dirty="0"/>
+          </a:p>
+        </p:txBody>
+      </p:sp>
+      <p:sp>
+        <p:nvSpPr>
+          <p:cNvPr id="3" name="Shape 1"/>
+          <p:cNvSpPr/>
+          <p:nvPr/>
+        </p:nvSpPr>
+        <p:spPr>
+          <a:xfrm>
+            <a:off x="731520" y="2103120"/>
+            <a:ext cx="502920" cy="502920"/>
+          </a:xfrm>
+          <a:prstGeom prst="ellipse">
+            <a:avLst/>
+          </a:prstGeom>
+          <a:solidFill>
+            <a:srgbClr val="C98A2C"/>
+          </a:solidFill>
+          <a:ln/>
+        </p:spPr>
+      </p:sp>
+      <p:sp>
+        <p:nvSpPr>
+          <p:cNvPr id="4" name="Text 2"/>
+          <p:cNvSpPr/>
+          <p:nvPr/>
+        </p:nvSpPr>
+        <p:spPr>
+          <a:xfrm>
+            <a:off x="731520" y="2103120"/>
+            <a:ext cx="502920" cy="502920"/>
+          </a:xfrm>
+          <a:prstGeom prst="rect">
+            <a:avLst/>
+          </a:prstGeom>
+          <a:noFill/>
+          <a:ln/>
+        </p:spPr>
+        <p:txBody>
+          <a:bodyPr wrap="square" lIns="0" tIns="0" rIns="0" bIns="0" rtlCol="0" anchor="ctr"/>
+          <a:lstStyle/>
+          <a:p>
+            <a:pPr algn="ctr" indent="0" marL="0">
+              <a:buNone/>
+            </a:pPr>
+            <a:r>
+              <a:rPr lang="en-US" sz="1800" b="1" dirty="0">
+                <a:solidFill>
+                  <a:srgbClr val="16374F"/>
+                </a:solidFill>
+                <a:latin typeface="Calibri" pitchFamily="34" charset="0"/>
+                <a:ea typeface="Calibri" pitchFamily="34" charset="-122"/>
+                <a:cs typeface="Calibri" pitchFamily="34" charset="-120"/>
+              </a:rPr>
+              <a:t>1</a:t>
+            </a:r>
+            <a:endParaRPr lang="en-US" sz="1800" dirty="0"/>
+          </a:p>
+        </p:txBody>
+      </p:sp>
+      <p:sp>
+        <p:nvSpPr>
+          <p:cNvPr id="5" name="Text 3"/>
+          <p:cNvSpPr/>
+          <p:nvPr/>
+        </p:nvSpPr>
+        <p:spPr>
+          <a:xfrm>
+            <a:off x="1417320" y="2084832"/>
+            <a:ext cx="9601200" cy="548640"/>
+          </a:xfrm>
+          <a:prstGeom prst="rect">
+            <a:avLst/>
+          </a:prstGeom>
+          <a:noFill/>
+          <a:ln/>
+        </p:spPr>
+        <p:txBody>
+          <a:bodyPr wrap="square" lIns="0" tIns="0" rIns="0" bIns="0" rtlCol="0" anchor="ctr"/>
+          <a:lstStyle/>
+          <a:p>
+            <a:pPr indent="0" marL="0">
+              <a:buNone/>
+            </a:pPr>
+            <a:r>
+              <a:rPr lang="en-US" sz="1700" dirty="0">
+                <a:solidFill>
+                  <a:srgbClr val="FFFFFF"/>
+                </a:solidFill>
+                <a:latin typeface="Calibri" pitchFamily="34" charset="0"/>
+                <a:ea typeface="Calibri" pitchFamily="34" charset="-122"/>
+                <a:cs typeface="Calibri" pitchFamily="34" charset="-120"/>
+              </a:rPr>
+              <a:t>Pick a new topic — any feature, codebase, or workflow</a:t>
+            </a:r>
+            <a:endParaRPr lang="en-US" sz="1700" dirty="0"/>
+          </a:p>
+        </p:txBody>
+      </p:sp>
+      <p:sp>
+        <p:nvSpPr>
+          <p:cNvPr id="6" name="Shape 4"/>
+          <p:cNvSpPr/>
+          <p:nvPr/>
+        </p:nvSpPr>
+        <p:spPr>
+          <a:xfrm>
+            <a:off x="731520" y="2971800"/>
+            <a:ext cx="502920" cy="502920"/>
+          </a:xfrm>
+          <a:prstGeom prst="ellipse">
+            <a:avLst/>
+          </a:prstGeom>
+          <a:solidFill>
+            <a:srgbClr val="C98A2C"/>
+          </a:solidFill>
+          <a:ln/>
+        </p:spPr>
+      </p:sp>
+      <p:sp>
+        <p:nvSpPr>
+          <p:cNvPr id="7" name="Text 5"/>
+          <p:cNvSpPr/>
+          <p:nvPr/>
+        </p:nvSpPr>
+        <p:spPr>
+          <a:xfrm>
+            <a:off x="731520" y="2971800"/>
+            <a:ext cx="502920" cy="502920"/>
+          </a:xfrm>
+          <a:prstGeom prst="rect">
+            <a:avLst/>
+          </a:prstGeom>
+          <a:noFill/>
+          <a:ln/>
+        </p:spPr>
+        <p:txBody>
+          <a:bodyPr wrap="square" lIns="0" tIns="0" rIns="0" bIns="0" rtlCol="0" anchor="ctr"/>
+          <a:lstStyle/>
+          <a:p>
+            <a:pPr algn="ctr" indent="0" marL="0">
+              <a:buNone/>
+            </a:pPr>
+            <a:r>
+              <a:rPr lang="en-US" sz="1800" b="1" dirty="0">
+                <a:solidFill>
+                  <a:srgbClr val="16374F"/>
+                </a:solidFill>
+                <a:latin typeface="Calibri" pitchFamily="34" charset="0"/>
+                <a:ea typeface="Calibri" pitchFamily="34" charset="-122"/>
+                <a:cs typeface="Calibri" pitchFamily="34" charset="-120"/>
+              </a:rPr>
+              <a:t>2</a:t>
+            </a:r>
+            <a:endParaRPr lang="en-US" sz="1800" dirty="0"/>
+          </a:p>
+        </p:txBody>
+      </p:sp>
+      <p:sp>
+        <p:nvSpPr>
+          <p:cNvPr id="8" name="Text 6"/>
+          <p:cNvSpPr/>
+          <p:nvPr/>
+        </p:nvSpPr>
+        <p:spPr>
+          <a:xfrm>
+            <a:off x="1417320" y="2953512"/>
+            <a:ext cx="9601200" cy="548640"/>
+          </a:xfrm>
+          <a:prstGeom prst="rect">
+            <a:avLst/>
+          </a:prstGeom>
+          <a:noFill/>
+          <a:ln/>
+        </p:spPr>
+        <p:txBody>
+          <a:bodyPr wrap="square" lIns="0" tIns="0" rIns="0" bIns="0" rtlCol="0" anchor="ctr"/>
+          <a:lstStyle/>
+          <a:p>
+            <a:pPr indent="0" marL="0">
+              <a:buNone/>
+            </a:pPr>
+            <a:r>
+              <a:rPr lang="en-US" sz="1700" dirty="0">
+                <a:solidFill>
+                  <a:srgbClr val="FFFFFF"/>
+                </a:solidFill>
+                <a:latin typeface="Calibri" pitchFamily="34" charset="0"/>
+                <a:ea typeface="Calibri" pitchFamily="34" charset="-122"/>
+                <a:cs typeface="Calibri" pitchFamily="34" charset="-120"/>
+              </a:rPr>
+              <a:t>Start at Step 1 of the Reusable Prompt Template</a:t>
+            </a:r>
+            <a:endParaRPr lang="en-US" sz="1700" dirty="0"/>
+          </a:p>
+        </p:txBody>
+      </p:sp>
+      <p:sp>
+        <p:nvSpPr>
+          <p:cNvPr id="9" name="Shape 7"/>
+          <p:cNvSpPr/>
+          <p:nvPr/>
+        </p:nvSpPr>
+        <p:spPr>
+          <a:xfrm>
+            <a:off x="731520" y="3840480"/>
+            <a:ext cx="502920" cy="502920"/>
+          </a:xfrm>
+          <a:prstGeom prst="ellipse">
+            <a:avLst/>
+          </a:prstGeom>
+          <a:solidFill>
+            <a:srgbClr val="C98A2C"/>
+          </a:solidFill>
+          <a:ln/>
+        </p:spPr>
+      </p:sp>
+      <p:sp>
+        <p:nvSpPr>
+          <p:cNvPr id="10" name="Text 8"/>
+          <p:cNvSpPr/>
+          <p:nvPr/>
+        </p:nvSpPr>
+        <p:spPr>
+          <a:xfrm>
+            <a:off x="731520" y="3840480"/>
+            <a:ext cx="502920" cy="502920"/>
+          </a:xfrm>
+          <a:prstGeom prst="rect">
+            <a:avLst/>
+          </a:prstGeom>
+          <a:noFill/>
+          <a:ln/>
+        </p:spPr>
+        <p:txBody>
+          <a:bodyPr wrap="square" lIns="0" tIns="0" rIns="0" bIns="0" rtlCol="0" anchor="ctr"/>
+          <a:lstStyle/>
+          <a:p>
+            <a:pPr algn="ctr" indent="0" marL="0">
+              <a:buNone/>
+            </a:pPr>
+            <a:r>
+              <a:rPr lang="en-US" sz="1800" b="1" dirty="0">
+                <a:solidFill>
+                  <a:srgbClr val="16374F"/>
+                </a:solidFill>
+                <a:latin typeface="Calibri" pitchFamily="34" charset="0"/>
+                <a:ea typeface="Calibri" pitchFamily="34" charset="-122"/>
+                <a:cs typeface="Calibri" pitchFamily="34" charset="-120"/>
+              </a:rPr>
+              <a:t>3</a:t>
+            </a:r>
+            <a:endParaRPr lang="en-US" sz="1800" dirty="0"/>
+          </a:p>
+        </p:txBody>
+      </p:sp>
+      <p:sp>
+        <p:nvSpPr>
+          <p:cNvPr id="11" name="Text 9"/>
+          <p:cNvSpPr/>
+          <p:nvPr/>
+        </p:nvSpPr>
+        <p:spPr>
+          <a:xfrm>
+            <a:off x="1417320" y="3822192"/>
+            <a:ext cx="9601200" cy="548640"/>
+          </a:xfrm>
+          <a:prstGeom prst="rect">
+            <a:avLst/>
+          </a:prstGeom>
+          <a:noFill/>
+          <a:ln/>
+        </p:spPr>
+        <p:txBody>
+          <a:bodyPr wrap="square" lIns="0" tIns="0" rIns="0" bIns="0" rtlCol="0" anchor="ctr"/>
+          <a:lstStyle/>
+          <a:p>
+            <a:pPr indent="0" marL="0">
+              <a:buNone/>
+            </a:pPr>
+            <a:r>
+              <a:rPr lang="en-US" sz="1700" dirty="0">
+                <a:solidFill>
+                  <a:srgbClr val="FFFFFF"/>
+                </a:solidFill>
+                <a:latin typeface="Calibri" pitchFamily="34" charset="0"/>
+                <a:ea typeface="Calibri" pitchFamily="34" charset="-122"/>
+                <a:cs typeface="Calibri" pitchFamily="34" charset="-120"/>
+              </a:rPr>
+              <a:t>Reuse the verified helper scripts — don't rediscover the same 3 bugs</a:t>
+            </a:r>
+            <a:endParaRPr lang="en-US" sz="1700" dirty="0"/>
+          </a:p>
+        </p:txBody>
+      </p:sp>
+      <p:sp>
+        <p:nvSpPr>
+          <p:cNvPr id="12" name="Text 10"/>
+          <p:cNvSpPr/>
+          <p:nvPr/>
+        </p:nvSpPr>
+        <p:spPr>
+          <a:xfrm>
+            <a:off x="731520" y="6126480"/>
+            <a:ext cx="10515600" cy="365760"/>
+          </a:xfrm>
+          <a:prstGeom prst="rect">
+            <a:avLst/>
+          </a:prstGeom>
+          <a:noFill/>
+          <a:ln/>
+        </p:spPr>
+        <p:txBody>
+          <a:bodyPr wrap="square" lIns="0" tIns="0" rIns="0" bIns="0" rtlCol="0" anchor="ctr"/>
+          <a:lstStyle/>
+          <a:p>
+            <a:pPr indent="0" marL="0">
+              <a:buNone/>
+            </a:pPr>
+            <a:r>
+              <a:rPr lang="en-US" sz="1200" i="1" dirty="0">
+                <a:solidFill>
+                  <a:srgbClr val="9FB6CE"/>
+                </a:solidFill>
+                <a:latin typeface="Calibri" pitchFamily="34" charset="0"/>
+                <a:ea typeface="Calibri" pitchFamily="34" charset="-122"/>
+                <a:cs typeface="Calibri" pitchFamily="34" charset="-120"/>
+              </a:rPr>
+              <a:t>Reference: GSTACK_TUTORIAL_1_WORKFLOW_PLAYBOOK.docx</a:t>
+            </a:r>
+            <a:endParaRPr lang="en-US" sz="1200" dirty="0"/>
+          </a:p>
+        </p:txBody>
+      </p:sp>
+    </p:spTree>
+  </p:cSld>
+  <p:clrMapOvr>
+    <a:masterClrMapping/>
+  </p:clrMapOvr>
+</p:sld>
+</file>
+
 <file path=ppt/slides/slide2.xml><?xml version="1.0" encoding="utf-8"?>
 <p:sld xmlns:a="http://schemas.openxmlformats.org/drawingml/2006/main" xmlns:r="http://schemas.openxmlformats.org/officeDocument/2006/relationships" xmlns:p="http://schemas.openxmlformats.org/presentationml/2006/main">
   <p:cSld name="Slide 2">
@@ -5670,7 +6252,7 @@
     <p:bg>
       <p:bgPr>
         <a:solidFill>
-          <a:srgbClr val="16374F"/>
+          <a:srgbClr val="FFFFFF"/>
         </a:solidFill>
       </p:bgPr>
     </p:bg>
@@ -5696,8 +6278,8 @@
         </p:nvSpPr>
         <p:spPr>
           <a:xfrm>
-            <a:off x="731520" y="731520"/>
-            <a:ext cx="10698480" cy="914400"/>
+            <a:off x="548640" y="457200"/>
+            <a:ext cx="11064240" cy="822960"/>
           </a:xfrm>
           <a:prstGeom prst="rect">
             <a:avLst/>
@@ -5713,17 +6295,17 @@
               <a:buNone/>
             </a:pPr>
             <a:r>
-              <a:rPr lang="en-US" sz="3600" b="1" dirty="0">
-                <a:solidFill>
-                  <a:srgbClr val="FFFFFF"/>
+              <a:rPr lang="en-US" sz="2200" b="1" dirty="0">
+                <a:solidFill>
+                  <a:srgbClr val="1F4E78"/>
                 </a:solidFill>
                 <a:latin typeface="Cambria" pitchFamily="34" charset="0"/>
                 <a:ea typeface="Cambria" pitchFamily="34" charset="-122"/>
                 <a:cs typeface="Cambria" pitchFamily="34" charset="-120"/>
               </a:rPr>
-              <a:t>Ready for Tutorial #2</a:t>
-            </a:r>
-            <a:endParaRPr lang="en-US" sz="3600" dirty="0"/>
+              <a:t>One concept, four files, four verifications — that's what a revision costs</a:t>
+            </a:r>
+            <a:endParaRPr lang="en-US" sz="2200" dirty="0"/>
           </a:p>
         </p:txBody>
       </p:sp>
@@ -5735,14 +6317,14 @@
         </p:nvSpPr>
         <p:spPr>
           <a:xfrm>
-            <a:off x="731520" y="2103120"/>
-            <a:ext cx="502920" cy="502920"/>
+            <a:off x="640080" y="1600200"/>
+            <a:ext cx="411480" cy="411480"/>
           </a:xfrm>
           <a:prstGeom prst="ellipse">
             <a:avLst/>
           </a:prstGeom>
           <a:solidFill>
-            <a:srgbClr val="C98A2C"/>
+            <a:srgbClr val="1F4E78"/>
           </a:solidFill>
           <a:ln/>
         </p:spPr>
@@ -5755,8 +6337,8 @@
         </p:nvSpPr>
         <p:spPr>
           <a:xfrm>
-            <a:off x="731520" y="2103120"/>
-            <a:ext cx="502920" cy="502920"/>
+            <a:off x="640080" y="1600200"/>
+            <a:ext cx="411480" cy="411480"/>
           </a:xfrm>
           <a:prstGeom prst="rect">
             <a:avLst/>
@@ -5772,9 +6354,9 @@
               <a:buNone/>
             </a:pPr>
             <a:r>
-              <a:rPr lang="en-US" sz="1800" b="1" dirty="0">
-                <a:solidFill>
-                  <a:srgbClr val="16374F"/>
+              <a:rPr lang="en-US" sz="1400" b="1" dirty="0">
+                <a:solidFill>
+                  <a:srgbClr val="FFFFFF"/>
                 </a:solidFill>
                 <a:latin typeface="Calibri" pitchFamily="34" charset="0"/>
                 <a:ea typeface="Calibri" pitchFamily="34" charset="-122"/>
@@ -5782,7 +6364,7 @@
               </a:rPr>
               <a:t>1</a:t>
             </a:r>
-            <a:endParaRPr lang="en-US" sz="1800" dirty="0"/>
+            <a:endParaRPr lang="en-US" sz="1400" dirty="0"/>
           </a:p>
         </p:txBody>
       </p:sp>
@@ -5794,8 +6376,8 @@
         </p:nvSpPr>
         <p:spPr>
           <a:xfrm>
-            <a:off x="1417320" y="2084832"/>
-            <a:ext cx="9601200" cy="548640"/>
+            <a:off x="1234440" y="1554480"/>
+            <a:ext cx="9875520" cy="594360"/>
           </a:xfrm>
           <a:prstGeom prst="rect">
             <a:avLst/>
@@ -5811,7 +6393,66 @@
               <a:buNone/>
             </a:pPr>
             <a:r>
-              <a:rPr lang="en-US" sz="1700" dirty="0">
+              <a:rPr lang="en-US" sz="1350" dirty="0">
+                <a:solidFill>
+                  <a:srgbClr val="1F1F1F"/>
+                </a:solidFill>
+                <a:latin typeface="Calibri" pitchFamily="34" charset="0"/>
+                <a:ea typeface="Calibri" pitchFamily="34" charset="-122"/>
+                <a:cs typeface="Calibri" pitchFamily="34" charset="-120"/>
+              </a:rPr>
+              <a:t>A user question surfaces a real gap (not a bug report — a genuine point of confusion)</a:t>
+            </a:r>
+            <a:endParaRPr lang="en-US" sz="1350" dirty="0"/>
+          </a:p>
+        </p:txBody>
+      </p:sp>
+      <p:sp>
+        <p:nvSpPr>
+          <p:cNvPr id="6" name="Shape 4"/>
+          <p:cNvSpPr/>
+          <p:nvPr/>
+        </p:nvSpPr>
+        <p:spPr>
+          <a:xfrm>
+            <a:off x="640080" y="2350008"/>
+            <a:ext cx="411480" cy="411480"/>
+          </a:xfrm>
+          <a:prstGeom prst="ellipse">
+            <a:avLst/>
+          </a:prstGeom>
+          <a:solidFill>
+            <a:srgbClr val="1F4E78"/>
+          </a:solidFill>
+          <a:ln/>
+        </p:spPr>
+      </p:sp>
+      <p:sp>
+        <p:nvSpPr>
+          <p:cNvPr id="7" name="Text 5"/>
+          <p:cNvSpPr/>
+          <p:nvPr/>
+        </p:nvSpPr>
+        <p:spPr>
+          <a:xfrm>
+            <a:off x="640080" y="2350008"/>
+            <a:ext cx="411480" cy="411480"/>
+          </a:xfrm>
+          <a:prstGeom prst="rect">
+            <a:avLst/>
+          </a:prstGeom>
+          <a:noFill/>
+          <a:ln/>
+        </p:spPr>
+        <p:txBody>
+          <a:bodyPr wrap="square" lIns="0" tIns="0" rIns="0" bIns="0" rtlCol="0" anchor="ctr"/>
+          <a:lstStyle/>
+          <a:p>
+            <a:pPr algn="ctr" indent="0" marL="0">
+              <a:buNone/>
+            </a:pPr>
+            <a:r>
+              <a:rPr lang="en-US" sz="1400" b="1" dirty="0">
                 <a:solidFill>
                   <a:srgbClr val="FFFFFF"/>
                 </a:solidFill>
@@ -5819,42 +6460,81 @@
                 <a:ea typeface="Calibri" pitchFamily="34" charset="-122"/>
                 <a:cs typeface="Calibri" pitchFamily="34" charset="-120"/>
               </a:rPr>
-              <a:t>Pick a new topic — any feature, codebase, or workflow</a:t>
-            </a:r>
-            <a:endParaRPr lang="en-US" sz="1700" dirty="0"/>
-          </a:p>
-        </p:txBody>
-      </p:sp>
-      <p:sp>
-        <p:nvSpPr>
-          <p:cNvPr id="6" name="Shape 4"/>
-          <p:cNvSpPr/>
-          <p:nvPr/>
-        </p:nvSpPr>
-        <p:spPr>
-          <a:xfrm>
-            <a:off x="731520" y="2971800"/>
-            <a:ext cx="502920" cy="502920"/>
+              <a:t>2</a:t>
+            </a:r>
+            <a:endParaRPr lang="en-US" sz="1400" dirty="0"/>
+          </a:p>
+        </p:txBody>
+      </p:sp>
+      <p:sp>
+        <p:nvSpPr>
+          <p:cNvPr id="8" name="Text 6"/>
+          <p:cNvSpPr/>
+          <p:nvPr/>
+        </p:nvSpPr>
+        <p:spPr>
+          <a:xfrm>
+            <a:off x="1234440" y="2304288"/>
+            <a:ext cx="9875520" cy="594360"/>
+          </a:xfrm>
+          <a:prstGeom prst="rect">
+            <a:avLst/>
+          </a:prstGeom>
+          <a:noFill/>
+          <a:ln/>
+        </p:spPr>
+        <p:txBody>
+          <a:bodyPr wrap="square" lIns="0" tIns="0" rIns="0" bIns="0" rtlCol="0" anchor="ctr"/>
+          <a:lstStyle/>
+          <a:p>
+            <a:pPr indent="0" marL="0">
+              <a:buNone/>
+            </a:pPr>
+            <a:r>
+              <a:rPr lang="en-US" sz="1350" dirty="0">
+                <a:solidFill>
+                  <a:srgbClr val="1F1F1F"/>
+                </a:solidFill>
+                <a:latin typeface="Calibri" pitchFamily="34" charset="0"/>
+                <a:ea typeface="Calibri" pitchFamily="34" charset="-122"/>
+                <a:cs typeface="Calibri" pitchFamily="34" charset="-120"/>
+              </a:rPr>
+              <a:t>Update the meta-playbook FIRST — forces the concept to be fully worked out</a:t>
+            </a:r>
+            <a:endParaRPr lang="en-US" sz="1350" dirty="0"/>
+          </a:p>
+        </p:txBody>
+      </p:sp>
+      <p:sp>
+        <p:nvSpPr>
+          <p:cNvPr id="9" name="Shape 7"/>
+          <p:cNvSpPr/>
+          <p:nvPr/>
+        </p:nvSpPr>
+        <p:spPr>
+          <a:xfrm>
+            <a:off x="640080" y="3099816"/>
+            <a:ext cx="411480" cy="411480"/>
           </a:xfrm>
           <a:prstGeom prst="ellipse">
             <a:avLst/>
           </a:prstGeom>
           <a:solidFill>
-            <a:srgbClr val="C98A2C"/>
+            <a:srgbClr val="1F4E78"/>
           </a:solidFill>
           <a:ln/>
         </p:spPr>
       </p:sp>
       <p:sp>
         <p:nvSpPr>
-          <p:cNvPr id="7" name="Text 5"/>
-          <p:cNvSpPr/>
-          <p:nvPr/>
-        </p:nvSpPr>
-        <p:spPr>
-          <a:xfrm>
-            <a:off x="731520" y="2971800"/>
-            <a:ext cx="502920" cy="502920"/>
+          <p:cNvPr id="10" name="Text 8"/>
+          <p:cNvSpPr/>
+          <p:nvPr/>
+        </p:nvSpPr>
+        <p:spPr>
+          <a:xfrm>
+            <a:off x="640080" y="3099816"/>
+            <a:ext cx="411480" cy="411480"/>
           </a:xfrm>
           <a:prstGeom prst="rect">
             <a:avLst/>
@@ -5870,30 +6550,30 @@
               <a:buNone/>
             </a:pPr>
             <a:r>
-              <a:rPr lang="en-US" sz="1800" b="1" dirty="0">
-                <a:solidFill>
-                  <a:srgbClr val="16374F"/>
-                </a:solidFill>
-                <a:latin typeface="Calibri" pitchFamily="34" charset="0"/>
-                <a:ea typeface="Calibri" pitchFamily="34" charset="-122"/>
-                <a:cs typeface="Calibri" pitchFamily="34" charset="-120"/>
-              </a:rPr>
-              <a:t>2</a:t>
-            </a:r>
-            <a:endParaRPr lang="en-US" sz="1800" dirty="0"/>
-          </a:p>
-        </p:txBody>
-      </p:sp>
-      <p:sp>
-        <p:nvSpPr>
-          <p:cNvPr id="8" name="Text 6"/>
-          <p:cNvSpPr/>
-          <p:nvPr/>
-        </p:nvSpPr>
-        <p:spPr>
-          <a:xfrm>
-            <a:off x="1417320" y="2953512"/>
-            <a:ext cx="9601200" cy="548640"/>
+              <a:rPr lang="en-US" sz="1400" b="1" dirty="0">
+                <a:solidFill>
+                  <a:srgbClr val="FFFFFF"/>
+                </a:solidFill>
+                <a:latin typeface="Calibri" pitchFamily="34" charset="0"/>
+                <a:ea typeface="Calibri" pitchFamily="34" charset="-122"/>
+                <a:cs typeface="Calibri" pitchFamily="34" charset="-120"/>
+              </a:rPr>
+              <a:t>3</a:t>
+            </a:r>
+            <a:endParaRPr lang="en-US" sz="1400" dirty="0"/>
+          </a:p>
+        </p:txBody>
+      </p:sp>
+      <p:sp>
+        <p:nvSpPr>
+          <p:cNvPr id="11" name="Text 9"/>
+          <p:cNvSpPr/>
+          <p:nvPr/>
+        </p:nvSpPr>
+        <p:spPr>
+          <a:xfrm>
+            <a:off x="1234440" y="3054096"/>
+            <a:ext cx="9875520" cy="594360"/>
           </a:xfrm>
           <a:prstGeom prst="rect">
             <a:avLst/>
@@ -5909,7 +6589,66 @@
               <a:buNone/>
             </a:pPr>
             <a:r>
-              <a:rPr lang="en-US" sz="1700" dirty="0">
+              <a:rPr lang="en-US" sz="1350" dirty="0">
+                <a:solidFill>
+                  <a:srgbClr val="1F1F1F"/>
+                </a:solidFill>
+                <a:latin typeface="Calibri" pitchFamily="34" charset="0"/>
+                <a:ea typeface="Calibri" pitchFamily="34" charset="-122"/>
+                <a:cs typeface="Calibri" pitchFamily="34" charset="-120"/>
+              </a:rPr>
+              <a:t>Build any new mechanism the concept needs (e.g. a real GitHub Issue Template)</a:t>
+            </a:r>
+            <a:endParaRPr lang="en-US" sz="1350" dirty="0"/>
+          </a:p>
+        </p:txBody>
+      </p:sp>
+      <p:sp>
+        <p:nvSpPr>
+          <p:cNvPr id="12" name="Shape 10"/>
+          <p:cNvSpPr/>
+          <p:nvPr/>
+        </p:nvSpPr>
+        <p:spPr>
+          <a:xfrm>
+            <a:off x="640080" y="3849624"/>
+            <a:ext cx="411480" cy="411480"/>
+          </a:xfrm>
+          <a:prstGeom prst="ellipse">
+            <a:avLst/>
+          </a:prstGeom>
+          <a:solidFill>
+            <a:srgbClr val="1F4E78"/>
+          </a:solidFill>
+          <a:ln/>
+        </p:spPr>
+      </p:sp>
+      <p:sp>
+        <p:nvSpPr>
+          <p:cNvPr id="13" name="Text 11"/>
+          <p:cNvSpPr/>
+          <p:nvPr/>
+        </p:nvSpPr>
+        <p:spPr>
+          <a:xfrm>
+            <a:off x="640080" y="3849624"/>
+            <a:ext cx="411480" cy="411480"/>
+          </a:xfrm>
+          <a:prstGeom prst="rect">
+            <a:avLst/>
+          </a:prstGeom>
+          <a:noFill/>
+          <a:ln/>
+        </p:spPr>
+        <p:txBody>
+          <a:bodyPr wrap="square" lIns="0" tIns="0" rIns="0" bIns="0" rtlCol="0" anchor="ctr"/>
+          <a:lstStyle/>
+          <a:p>
+            <a:pPr algn="ctr" indent="0" marL="0">
+              <a:buNone/>
+            </a:pPr>
+            <a:r>
+              <a:rPr lang="en-US" sz="1400" b="1" dirty="0">
                 <a:solidFill>
                   <a:srgbClr val="FFFFFF"/>
                 </a:solidFill>
@@ -5917,42 +6656,81 @@
                 <a:ea typeface="Calibri" pitchFamily="34" charset="-122"/>
                 <a:cs typeface="Calibri" pitchFamily="34" charset="-120"/>
               </a:rPr>
-              <a:t>Start at Step 1 of the Reusable Prompt Template</a:t>
-            </a:r>
-            <a:endParaRPr lang="en-US" sz="1700" dirty="0"/>
-          </a:p>
-        </p:txBody>
-      </p:sp>
-      <p:sp>
-        <p:nvSpPr>
-          <p:cNvPr id="9" name="Shape 7"/>
-          <p:cNvSpPr/>
-          <p:nvPr/>
-        </p:nvSpPr>
-        <p:spPr>
-          <a:xfrm>
-            <a:off x="731520" y="3840480"/>
-            <a:ext cx="502920" cy="502920"/>
+              <a:t>4</a:t>
+            </a:r>
+            <a:endParaRPr lang="en-US" sz="1400" dirty="0"/>
+          </a:p>
+        </p:txBody>
+      </p:sp>
+      <p:sp>
+        <p:nvSpPr>
+          <p:cNvPr id="14" name="Text 12"/>
+          <p:cNvSpPr/>
+          <p:nvPr/>
+        </p:nvSpPr>
+        <p:spPr>
+          <a:xfrm>
+            <a:off x="1234440" y="3803904"/>
+            <a:ext cx="9875520" cy="594360"/>
+          </a:xfrm>
+          <a:prstGeom prst="rect">
+            <a:avLst/>
+          </a:prstGeom>
+          <a:noFill/>
+          <a:ln/>
+        </p:spPr>
+        <p:txBody>
+          <a:bodyPr wrap="square" lIns="0" tIns="0" rIns="0" bIns="0" rtlCol="0" anchor="ctr"/>
+          <a:lstStyle/>
+          <a:p>
+            <a:pPr indent="0" marL="0">
+              <a:buNone/>
+            </a:pPr>
+            <a:r>
+              <a:rPr lang="en-US" sz="1350" dirty="0">
+                <a:solidFill>
+                  <a:srgbClr val="1F1F1F"/>
+                </a:solidFill>
+                <a:latin typeface="Calibri" pitchFamily="34" charset="0"/>
+                <a:ea typeface="Calibri" pitchFamily="34" charset="-122"/>
+                <a:cs typeface="Calibri" pitchFamily="34" charset="-120"/>
+              </a:rPr>
+              <a:t>Propagate into all 4 student-facing files: EN docx, CN docx, EN deck, CN deck</a:t>
+            </a:r>
+            <a:endParaRPr lang="en-US" sz="1350" dirty="0"/>
+          </a:p>
+        </p:txBody>
+      </p:sp>
+      <p:sp>
+        <p:nvSpPr>
+          <p:cNvPr id="15" name="Shape 13"/>
+          <p:cNvSpPr/>
+          <p:nvPr/>
+        </p:nvSpPr>
+        <p:spPr>
+          <a:xfrm>
+            <a:off x="640080" y="4599432"/>
+            <a:ext cx="411480" cy="411480"/>
           </a:xfrm>
           <a:prstGeom prst="ellipse">
             <a:avLst/>
           </a:prstGeom>
           <a:solidFill>
-            <a:srgbClr val="C98A2C"/>
+            <a:srgbClr val="1F4E78"/>
           </a:solidFill>
           <a:ln/>
         </p:spPr>
       </p:sp>
       <p:sp>
         <p:nvSpPr>
-          <p:cNvPr id="10" name="Text 8"/>
-          <p:cNvSpPr/>
-          <p:nvPr/>
-        </p:nvSpPr>
-        <p:spPr>
-          <a:xfrm>
-            <a:off x="731520" y="3840480"/>
-            <a:ext cx="502920" cy="502920"/>
+          <p:cNvPr id="16" name="Text 14"/>
+          <p:cNvSpPr/>
+          <p:nvPr/>
+        </p:nvSpPr>
+        <p:spPr>
+          <a:xfrm>
+            <a:off x="640080" y="4599432"/>
+            <a:ext cx="411480" cy="411480"/>
           </a:xfrm>
           <a:prstGeom prst="rect">
             <a:avLst/>
@@ -5968,30 +6746,30 @@
               <a:buNone/>
             </a:pPr>
             <a:r>
-              <a:rPr lang="en-US" sz="1800" b="1" dirty="0">
-                <a:solidFill>
-                  <a:srgbClr val="16374F"/>
-                </a:solidFill>
-                <a:latin typeface="Calibri" pitchFamily="34" charset="0"/>
-                <a:ea typeface="Calibri" pitchFamily="34" charset="-122"/>
-                <a:cs typeface="Calibri" pitchFamily="34" charset="-120"/>
-              </a:rPr>
-              <a:t>3</a:t>
-            </a:r>
-            <a:endParaRPr lang="en-US" sz="1800" dirty="0"/>
-          </a:p>
-        </p:txBody>
-      </p:sp>
-      <p:sp>
-        <p:nvSpPr>
-          <p:cNvPr id="11" name="Text 9"/>
-          <p:cNvSpPr/>
-          <p:nvPr/>
-        </p:nvSpPr>
-        <p:spPr>
-          <a:xfrm>
-            <a:off x="1417320" y="3822192"/>
-            <a:ext cx="9601200" cy="548640"/>
+              <a:rPr lang="en-US" sz="1400" b="1" dirty="0">
+                <a:solidFill>
+                  <a:srgbClr val="FFFFFF"/>
+                </a:solidFill>
+                <a:latin typeface="Calibri" pitchFamily="34" charset="0"/>
+                <a:ea typeface="Calibri" pitchFamily="34" charset="-122"/>
+                <a:cs typeface="Calibri" pitchFamily="34" charset="-120"/>
+              </a:rPr>
+              <a:t>5</a:t>
+            </a:r>
+            <a:endParaRPr lang="en-US" sz="1400" dirty="0"/>
+          </a:p>
+        </p:txBody>
+      </p:sp>
+      <p:sp>
+        <p:nvSpPr>
+          <p:cNvPr id="17" name="Text 15"/>
+          <p:cNvSpPr/>
+          <p:nvPr/>
+        </p:nvSpPr>
+        <p:spPr>
+          <a:xfrm>
+            <a:off x="1234440" y="4553712"/>
+            <a:ext cx="9875520" cy="594360"/>
           </a:xfrm>
           <a:prstGeom prst="rect">
             <a:avLst/>
@@ -6007,7 +6785,66 @@
               <a:buNone/>
             </a:pPr>
             <a:r>
-              <a:rPr lang="en-US" sz="1700" dirty="0">
+              <a:rPr lang="en-US" sz="1350" dirty="0">
+                <a:solidFill>
+                  <a:srgbClr val="1F1F1F"/>
+                </a:solidFill>
+                <a:latin typeface="Calibri" pitchFamily="34" charset="0"/>
+                <a:ea typeface="Calibri" pitchFamily="34" charset="-122"/>
+                <a:cs typeface="Calibri" pitchFamily="34" charset="-120"/>
+              </a:rPr>
+              <a:t>Verify EACH file independently — schema, duplication, CJK font, geometry</a:t>
+            </a:r>
+            <a:endParaRPr lang="en-US" sz="1350" dirty="0"/>
+          </a:p>
+        </p:txBody>
+      </p:sp>
+      <p:sp>
+        <p:nvSpPr>
+          <p:cNvPr id="18" name="Shape 16"/>
+          <p:cNvSpPr/>
+          <p:nvPr/>
+        </p:nvSpPr>
+        <p:spPr>
+          <a:xfrm>
+            <a:off x="640080" y="5349240"/>
+            <a:ext cx="411480" cy="411480"/>
+          </a:xfrm>
+          <a:prstGeom prst="ellipse">
+            <a:avLst/>
+          </a:prstGeom>
+          <a:solidFill>
+            <a:srgbClr val="1F4E78"/>
+          </a:solidFill>
+          <a:ln/>
+        </p:spPr>
+      </p:sp>
+      <p:sp>
+        <p:nvSpPr>
+          <p:cNvPr id="19" name="Text 17"/>
+          <p:cNvSpPr/>
+          <p:nvPr/>
+        </p:nvSpPr>
+        <p:spPr>
+          <a:xfrm>
+            <a:off x="640080" y="5349240"/>
+            <a:ext cx="411480" cy="411480"/>
+          </a:xfrm>
+          <a:prstGeom prst="rect">
+            <a:avLst/>
+          </a:prstGeom>
+          <a:noFill/>
+          <a:ln/>
+        </p:spPr>
+        <p:txBody>
+          <a:bodyPr wrap="square" lIns="0" tIns="0" rIns="0" bIns="0" rtlCol="0" anchor="ctr"/>
+          <a:lstStyle/>
+          <a:p>
+            <a:pPr algn="ctr" indent="0" marL="0">
+              <a:buNone/>
+            </a:pPr>
+            <a:r>
+              <a:rPr lang="en-US" sz="1400" b="1" dirty="0">
                 <a:solidFill>
                   <a:srgbClr val="FFFFFF"/>
                 </a:solidFill>
@@ -6015,22 +6852,22 @@
                 <a:ea typeface="Calibri" pitchFamily="34" charset="-122"/>
                 <a:cs typeface="Calibri" pitchFamily="34" charset="-120"/>
               </a:rPr>
-              <a:t>Reuse the verified helper scripts — don't rediscover the same 3 bugs</a:t>
-            </a:r>
-            <a:endParaRPr lang="en-US" sz="1700" dirty="0"/>
-          </a:p>
-        </p:txBody>
-      </p:sp>
-      <p:sp>
-        <p:nvSpPr>
-          <p:cNvPr id="12" name="Text 10"/>
-          <p:cNvSpPr/>
-          <p:nvPr/>
-        </p:nvSpPr>
-        <p:spPr>
-          <a:xfrm>
-            <a:off x="731520" y="6126480"/>
-            <a:ext cx="10515600" cy="365760"/>
+              <a:t>6</a:t>
+            </a:r>
+            <a:endParaRPr lang="en-US" sz="1400" dirty="0"/>
+          </a:p>
+        </p:txBody>
+      </p:sp>
+      <p:sp>
+        <p:nvSpPr>
+          <p:cNvPr id="20" name="Text 18"/>
+          <p:cNvSpPr/>
+          <p:nvPr/>
+        </p:nvSpPr>
+        <p:spPr>
+          <a:xfrm>
+            <a:off x="1234440" y="5303520"/>
+            <a:ext cx="9875520" cy="594360"/>
           </a:xfrm>
           <a:prstGeom prst="rect">
             <a:avLst/>
@@ -6046,17 +6883,284 @@
               <a:buNone/>
             </a:pPr>
             <a:r>
-              <a:rPr lang="en-US" sz="1200" i="1" dirty="0">
-                <a:solidFill>
-                  <a:srgbClr val="9FB6CE"/>
-                </a:solidFill>
-                <a:latin typeface="Calibri" pitchFamily="34" charset="0"/>
-                <a:ea typeface="Calibri" pitchFamily="34" charset="-122"/>
-                <a:cs typeface="Calibri" pitchFamily="34" charset="-120"/>
-              </a:rPr>
-              <a:t>Reference: GSTACK_TUTORIAL_1_WORKFLOW_PLAYBOOK.docx</a:t>
-            </a:r>
-            <a:endParaRPr lang="en-US" sz="1200" dirty="0"/>
+              <a:rPr lang="en-US" sz="1350" dirty="0">
+                <a:solidFill>
+                  <a:srgbClr val="1F1F1F"/>
+                </a:solidFill>
+                <a:latin typeface="Calibri" pitchFamily="34" charset="0"/>
+                <a:ea typeface="Calibri" pitchFamily="34" charset="-122"/>
+                <a:cs typeface="Calibri" pitchFamily="34" charset="-120"/>
+              </a:rPr>
+              <a:t>Commit, push, then checksum-verify against GitHub — don't trust exit code alone</a:t>
+            </a:r>
+            <a:endParaRPr lang="en-US" sz="1350" dirty="0"/>
+          </a:p>
+        </p:txBody>
+      </p:sp>
+    </p:spTree>
+  </p:cSld>
+  <p:clrMapOvr>
+    <a:masterClrMapping/>
+  </p:clrMapOvr>
+</p:sld>
+</file>
+
+<file path=ppt/slides/slide9.xml><?xml version="1.0" encoding="utf-8"?>
+<p:sld xmlns:a="http://schemas.openxmlformats.org/drawingml/2006/main" xmlns:r="http://schemas.openxmlformats.org/officeDocument/2006/relationships" xmlns:p="http://schemas.openxmlformats.org/presentationml/2006/main">
+  <p:cSld name="Slide 9">
+    <p:bg>
+      <p:bgPr>
+        <a:solidFill>
+          <a:srgbClr val="FFFFFF"/>
+        </a:solidFill>
+      </p:bgPr>
+    </p:bg>
+    <p:spTree>
+      <p:nvGrpSpPr>
+        <p:cNvPr id="1" name=""/>
+        <p:cNvGrpSpPr/>
+        <p:nvPr/>
+      </p:nvGrpSpPr>
+      <p:grpSpPr>
+        <a:xfrm>
+          <a:off x="0" y="0"/>
+          <a:ext cx="0" cy="0"/>
+          <a:chOff x="0" y="0"/>
+          <a:chExt cx="0" cy="0"/>
+        </a:xfrm>
+      </p:grpSpPr>
+      <p:sp>
+        <p:nvSpPr>
+          <p:cNvPr id="2" name="Text 0"/>
+          <p:cNvSpPr/>
+          <p:nvPr/>
+        </p:nvSpPr>
+        <p:spPr>
+          <a:xfrm>
+            <a:off x="548640" y="457200"/>
+            <a:ext cx="11064240" cy="822960"/>
+          </a:xfrm>
+          <a:prstGeom prst="rect">
+            <a:avLst/>
+          </a:prstGeom>
+          <a:noFill/>
+          <a:ln/>
+        </p:spPr>
+        <p:txBody>
+          <a:bodyPr wrap="square" lIns="0" tIns="0" rIns="0" bIns="0" rtlCol="0" anchor="ctr"/>
+          <a:lstStyle/>
+          <a:p>
+            <a:pPr indent="0" marL="0">
+              <a:buNone/>
+            </a:pPr>
+            <a:r>
+              <a:rPr lang="en-US" sz="2200" b="1" dirty="0">
+                <a:solidFill>
+                  <a:srgbClr val="1F4E78"/>
+                </a:solidFill>
+                <a:latin typeface="Cambria" pitchFamily="34" charset="0"/>
+                <a:ea typeface="Cambria" pitchFamily="34" charset="-122"/>
+                <a:cs typeface="Cambria" pitchFamily="34" charset="-120"/>
+              </a:rPr>
+              <a:t>Font-coverage bugs cluster at code/URL boundaries inside translated text</a:t>
+            </a:r>
+            <a:endParaRPr lang="en-US" sz="2200" dirty="0"/>
+          </a:p>
+        </p:txBody>
+      </p:sp>
+      <p:pic>
+        <p:nvPicPr>
+          <p:cNvPr id="3" name="Image 0" descr="preencoded.png">    </p:cNvPr>
+          <p:cNvPicPr>
+            <a:picLocks noChangeAspect="1"/>
+          </p:cNvPicPr>
+          <p:nvPr/>
+        </p:nvPicPr>
+        <p:blipFill>
+          <a:blip r:embed="rId1"/>
+          <a:stretch>
+            <a:fillRect/>
+          </a:stretch>
+        </p:blipFill>
+        <p:spPr>
+          <a:xfrm>
+            <a:off x="822960" y="1828800"/>
+            <a:ext cx="914400" cy="914400"/>
+          </a:xfrm>
+          <a:prstGeom prst="rect">
+            <a:avLst/>
+          </a:prstGeom>
+        </p:spPr>
+      </p:pic>
+      <p:sp>
+        <p:nvSpPr>
+          <p:cNvPr id="4" name="Text 1"/>
+          <p:cNvSpPr/>
+          <p:nvPr/>
+        </p:nvSpPr>
+        <p:spPr>
+          <a:xfrm>
+            <a:off x="2011680" y="1828800"/>
+            <a:ext cx="9326880" cy="1463040"/>
+          </a:xfrm>
+          <a:prstGeom prst="rect">
+            <a:avLst/>
+          </a:prstGeom>
+          <a:noFill/>
+          <a:ln/>
+        </p:spPr>
+        <p:txBody>
+          <a:bodyPr wrap="square" lIns="0" tIns="0" rIns="0" bIns="0" rtlCol="0" anchor="t"/>
+          <a:lstStyle/>
+          <a:p>
+            <a:pPr indent="0" marL="0">
+              <a:buNone/>
+            </a:pPr>
+            <a:r>
+              <a:rPr lang="en-US" sz="1600" b="1" dirty="0">
+                <a:solidFill>
+                  <a:srgbClr val="1F4E78"/>
+                </a:solidFill>
+                <a:latin typeface="Calibri" pitchFamily="34" charset="0"/>
+                <a:ea typeface="Calibri" pitchFamily="34" charset="-122"/>
+                <a:cs typeface="Calibri" pitchFamily="34" charset="-120"/>
+              </a:rPr>
+              <a:t>What happened:  </a:t>
+            </a:r>
+            <a:pPr indent="0" marL="0">
+              <a:buNone/>
+            </a:pPr>
+            <a:r>
+              <a:rPr lang="en-US" sz="1600" dirty="0">
+                <a:solidFill>
+                  <a:srgbClr val="1F1F1F"/>
+                </a:solidFill>
+                <a:latin typeface="Calibri" pitchFamily="34" charset="0"/>
+                <a:ea typeface="Calibri" pitchFamily="34" charset="-122"/>
+                <a:cs typeface="Calibri" pitchFamily="34" charset="-120"/>
+              </a:rPr>
+              <a:t>a Chinese placeholder was embedded inside a monospace, Consolas-styled git command during translation — no CJK font was declared for that run, since the whole run was styled as "code," not "Chinese prose."</a:t>
+            </a:r>
+            <a:endParaRPr lang="en-US" sz="1600" dirty="0"/>
+          </a:p>
+        </p:txBody>
+      </p:sp>
+      <p:sp>
+        <p:nvSpPr>
+          <p:cNvPr id="5" name="Text 2"/>
+          <p:cNvSpPr/>
+          <p:nvPr/>
+        </p:nvSpPr>
+        <p:spPr>
+          <a:xfrm>
+            <a:off x="2011680" y="3383280"/>
+            <a:ext cx="9326880" cy="914400"/>
+          </a:xfrm>
+          <a:prstGeom prst="rect">
+            <a:avLst/>
+          </a:prstGeom>
+          <a:noFill/>
+          <a:ln/>
+        </p:spPr>
+        <p:txBody>
+          <a:bodyPr wrap="square" lIns="0" tIns="0" rIns="0" bIns="0" rtlCol="0" anchor="t"/>
+          <a:lstStyle/>
+          <a:p>
+            <a:pPr indent="0" marL="0">
+              <a:buNone/>
+            </a:pPr>
+            <a:r>
+              <a:rPr lang="en-US" sz="1600" b="1" dirty="0">
+                <a:solidFill>
+                  <a:srgbClr val="1F4E78"/>
+                </a:solidFill>
+                <a:latin typeface="Calibri" pitchFamily="34" charset="0"/>
+                <a:ea typeface="Calibri" pitchFamily="34" charset="-122"/>
+                <a:cs typeface="Calibri" pitchFamily="34" charset="-120"/>
+              </a:rPr>
+              <a:t>Fix:  </a:t>
+            </a:r>
+            <a:pPr indent="0" marL="0">
+              <a:buNone/>
+            </a:pPr>
+            <a:r>
+              <a:rPr lang="en-US" sz="1600" dirty="0">
+                <a:solidFill>
+                  <a:srgbClr val="1F1F1F"/>
+                </a:solidFill>
+                <a:latin typeface="Calibri" pitchFamily="34" charset="0"/>
+                <a:ea typeface="Calibri" pitchFamily="34" charset="-122"/>
+                <a:cs typeface="Calibri" pitchFamily="34" charset="-120"/>
+              </a:rPr>
+              <a:t>used an English placeholder there instead — GitHub usernames are ASCII-only anyway, so this was also simply more correct, not just a workaround.</a:t>
+            </a:r>
+            <a:endParaRPr lang="en-US" sz="1600" dirty="0"/>
+          </a:p>
+        </p:txBody>
+      </p:sp>
+      <p:sp>
+        <p:nvSpPr>
+          <p:cNvPr id="6" name="Shape 3"/>
+          <p:cNvSpPr/>
+          <p:nvPr/>
+        </p:nvSpPr>
+        <p:spPr>
+          <a:xfrm>
+            <a:off x="822960" y="4663440"/>
+            <a:ext cx="10515600" cy="1188720"/>
+          </a:xfrm>
+          <a:prstGeom prst="roundRect">
+            <a:avLst>
+              <a:gd name="adj" fmla="val 4615"/>
+            </a:avLst>
+          </a:prstGeom>
+          <a:solidFill>
+            <a:srgbClr val="FFF3E0"/>
+          </a:solidFill>
+          <a:ln w="19050">
+            <a:solidFill>
+              <a:srgbClr val="C98A2C"/>
+            </a:solidFill>
+            <a:prstDash val="solid"/>
+          </a:ln>
+        </p:spPr>
+      </p:sp>
+      <p:sp>
+        <p:nvSpPr>
+          <p:cNvPr id="7" name="Text 4"/>
+          <p:cNvSpPr/>
+          <p:nvPr/>
+        </p:nvSpPr>
+        <p:spPr>
+          <a:xfrm>
+            <a:off x="1097280" y="4846320"/>
+            <a:ext cx="9966960" cy="868680"/>
+          </a:xfrm>
+          <a:prstGeom prst="rect">
+            <a:avLst/>
+          </a:prstGeom>
+          <a:noFill/>
+          <a:ln/>
+        </p:spPr>
+        <p:txBody>
+          <a:bodyPr wrap="square" lIns="0" tIns="0" rIns="0" bIns="0" rtlCol="0" anchor="t"/>
+          <a:lstStyle/>
+          <a:p>
+            <a:pPr indent="0" marL="0">
+              <a:buNone/>
+            </a:pPr>
+            <a:r>
+              <a:rPr lang="en-US" sz="1400" i="1" dirty="0">
+                <a:solidFill>
+                  <a:srgbClr val="8A5A00"/>
+                </a:solidFill>
+                <a:latin typeface="Calibri" pitchFamily="34" charset="0"/>
+                <a:ea typeface="Calibri" pitchFamily="34" charset="-122"/>
+                <a:cs typeface="Calibri" pitchFamily="34" charset="-120"/>
+              </a:rPr>
+              <a:t>Lesson: a run mixing literal command syntax with translated prose is the highest-risk spot for a missing CJK font — higher risk than a plain paragraph of Chinese text. Check those runs first.</a:t>
+            </a:r>
+            <a:endParaRPr lang="en-US" sz="1400" dirty="0"/>
           </a:p>
         </p:txBody>
       </p:sp>

</xml_diff>